<commit_message>
created different folders to save different codes
keep - will keep for later publication
</commit_message>
<xml_diff>
--- a/behavioral_analyses/figures/manu_fig.pptx
+++ b/behavioral_analyses/figures/manu_fig.pptx
@@ -6,6 +6,7 @@
   </p:sldMasterIdLst>
   <p:sldIdLst>
     <p:sldId id="256" r:id="rId2"/>
+    <p:sldId id="257" r:id="rId3"/>
   </p:sldIdLst>
   <p:sldSz cx="12192000" cy="6858000"/>
   <p:notesSz cx="6858000" cy="9144000"/>
@@ -3323,358 +3324,6 @@
       </p:grpSpPr>
       <p:grpSp>
         <p:nvGrpSpPr>
-          <p:cNvPr id="43" name="Group 42">
-            <a:extLst>
-              <a:ext uri="{FF2B5EF4-FFF2-40B4-BE49-F238E27FC236}">
-                <a16:creationId xmlns:a16="http://schemas.microsoft.com/office/drawing/2014/main" id="{809352BF-AB55-CD44-66CF-BD50D0B8101B}"/>
-              </a:ext>
-            </a:extLst>
-          </p:cNvPr>
-          <p:cNvGrpSpPr/>
-          <p:nvPr/>
-        </p:nvGrpSpPr>
-        <p:grpSpPr>
-          <a:xfrm>
-            <a:off x="7945129" y="514353"/>
-            <a:ext cx="3098800" cy="6160767"/>
-            <a:chOff x="7945129" y="514353"/>
-            <a:chExt cx="3098800" cy="6160767"/>
-          </a:xfrm>
-        </p:grpSpPr>
-        <p:pic>
-          <p:nvPicPr>
-            <p:cNvPr id="5" name="Picture 4" descr="A graph with blue lines and white text&#10;&#10;AI-generated content may be incorrect.">
-              <a:extLst>
-                <a:ext uri="{FF2B5EF4-FFF2-40B4-BE49-F238E27FC236}">
-                  <a16:creationId xmlns:a16="http://schemas.microsoft.com/office/drawing/2014/main" id="{4ED21569-8588-C0CF-D581-AD92BB0999D2}"/>
-                </a:ext>
-              </a:extLst>
-            </p:cNvPr>
-            <p:cNvPicPr>
-              <a:picLocks noChangeAspect="1"/>
-            </p:cNvPicPr>
-            <p:nvPr/>
-          </p:nvPicPr>
-          <p:blipFill>
-            <a:blip r:embed="rId2"/>
-            <a:srcRect t="5083" b="2566"/>
-            <a:stretch>
-              <a:fillRect/>
-            </a:stretch>
-          </p:blipFill>
-          <p:spPr>
-            <a:xfrm>
-              <a:off x="7945129" y="3086100"/>
-              <a:ext cx="3098800" cy="3589020"/>
-            </a:xfrm>
-            <a:prstGeom prst="rect">
-              <a:avLst/>
-            </a:prstGeom>
-          </p:spPr>
-        </p:pic>
-        <p:pic>
-          <p:nvPicPr>
-            <p:cNvPr id="16" name="Picture 15" descr="A close-up of a brain&#10;&#10;AI-generated content may be incorrect.">
-              <a:extLst>
-                <a:ext uri="{FF2B5EF4-FFF2-40B4-BE49-F238E27FC236}">
-                  <a16:creationId xmlns:a16="http://schemas.microsoft.com/office/drawing/2014/main" id="{38D650EA-3246-A68F-0C1F-61DFD13C40F8}"/>
-                </a:ext>
-              </a:extLst>
-            </p:cNvPr>
-            <p:cNvPicPr>
-              <a:picLocks noChangeAspect="1"/>
-            </p:cNvPicPr>
-            <p:nvPr/>
-          </p:nvPicPr>
-          <p:blipFill>
-            <a:blip r:embed="rId3"/>
-            <a:srcRect l="45457" t="10580" b="44235"/>
-            <a:stretch>
-              <a:fillRect/>
-            </a:stretch>
-          </p:blipFill>
-          <p:spPr>
-            <a:xfrm>
-              <a:off x="8449381" y="1484858"/>
-              <a:ext cx="1744148" cy="1675984"/>
-            </a:xfrm>
-            <a:prstGeom prst="rect">
-              <a:avLst/>
-            </a:prstGeom>
-          </p:spPr>
-        </p:pic>
-        <p:grpSp>
-          <p:nvGrpSpPr>
-            <p:cNvPr id="18" name="Group 17">
-              <a:extLst>
-                <a:ext uri="{FF2B5EF4-FFF2-40B4-BE49-F238E27FC236}">
-                  <a16:creationId xmlns:a16="http://schemas.microsoft.com/office/drawing/2014/main" id="{19689F6B-6A99-E535-9177-112DAC3886D7}"/>
-                </a:ext>
-              </a:extLst>
-            </p:cNvPr>
-            <p:cNvGrpSpPr/>
-            <p:nvPr/>
-          </p:nvGrpSpPr>
-          <p:grpSpPr>
-            <a:xfrm>
-              <a:off x="8395854" y="514353"/>
-              <a:ext cx="2531679" cy="956148"/>
-              <a:chOff x="8395854" y="514353"/>
-              <a:chExt cx="2531679" cy="956148"/>
-            </a:xfrm>
-          </p:grpSpPr>
-          <p:grpSp>
-            <p:nvGrpSpPr>
-              <p:cNvPr id="14" name="Group 13">
-                <a:extLst>
-                  <a:ext uri="{FF2B5EF4-FFF2-40B4-BE49-F238E27FC236}">
-                    <a16:creationId xmlns:a16="http://schemas.microsoft.com/office/drawing/2014/main" id="{AD61AEA9-AC21-1581-7918-1AA28346CF7E}"/>
-                  </a:ext>
-                </a:extLst>
-              </p:cNvPr>
-              <p:cNvGrpSpPr/>
-              <p:nvPr/>
-            </p:nvGrpSpPr>
-            <p:grpSpPr>
-              <a:xfrm>
-                <a:off x="8502474" y="528710"/>
-                <a:ext cx="2336059" cy="927433"/>
-                <a:chOff x="831958" y="330200"/>
-                <a:chExt cx="8601328" cy="3414793"/>
-              </a:xfrm>
-            </p:grpSpPr>
-            <p:pic>
-              <p:nvPicPr>
-                <p:cNvPr id="12" name="Picture 11" descr="A group of blue and white brain images&#10;&#10;AI-generated content may be incorrect.">
-                  <a:extLst>
-                    <a:ext uri="{FF2B5EF4-FFF2-40B4-BE49-F238E27FC236}">
-                      <a16:creationId xmlns:a16="http://schemas.microsoft.com/office/drawing/2014/main" id="{5445883F-54E9-499C-E520-9EB0548950FA}"/>
-                    </a:ext>
-                  </a:extLst>
-                </p:cNvPr>
-                <p:cNvPicPr>
-                  <a:picLocks noChangeAspect="1"/>
-                </p:cNvPicPr>
-                <p:nvPr/>
-              </p:nvPicPr>
-              <p:blipFill>
-                <a:blip r:embed="rId4"/>
-                <a:srcRect t="11299" b="48192"/>
-                <a:stretch>
-                  <a:fillRect/>
-                </a:stretch>
-              </p:blipFill>
-              <p:spPr>
-                <a:xfrm>
-                  <a:off x="3520900" y="650929"/>
-                  <a:ext cx="5912386" cy="2778072"/>
-                </a:xfrm>
-                <a:prstGeom prst="rect">
-                  <a:avLst/>
-                </a:prstGeom>
-              </p:spPr>
-            </p:pic>
-            <p:pic>
-              <p:nvPicPr>
-                <p:cNvPr id="13" name="Picture 12" descr="A group of blue and white brain images&#10;&#10;AI-generated content may be incorrect.">
-                  <a:extLst>
-                    <a:ext uri="{FF2B5EF4-FFF2-40B4-BE49-F238E27FC236}">
-                      <a16:creationId xmlns:a16="http://schemas.microsoft.com/office/drawing/2014/main" id="{DDF76CE9-725C-A891-90E5-71DC290E6285}"/>
-                    </a:ext>
-                  </a:extLst>
-                </p:cNvPr>
-                <p:cNvPicPr>
-                  <a:picLocks noChangeAspect="1"/>
-                </p:cNvPicPr>
-                <p:nvPr/>
-              </p:nvPicPr>
-              <p:blipFill>
-                <a:blip r:embed="rId4"/>
-                <a:srcRect t="50207" r="52577"/>
-                <a:stretch>
-                  <a:fillRect/>
-                </a:stretch>
-              </p:blipFill>
-              <p:spPr>
-                <a:xfrm>
-                  <a:off x="831958" y="330200"/>
-                  <a:ext cx="2803793" cy="3414793"/>
-                </a:xfrm>
-                <a:prstGeom prst="rect">
-                  <a:avLst/>
-                </a:prstGeom>
-              </p:spPr>
-            </p:pic>
-          </p:grpSp>
-          <p:sp>
-            <p:nvSpPr>
-              <p:cNvPr id="17" name="Rounded Rectangle 16">
-                <a:extLst>
-                  <a:ext uri="{FF2B5EF4-FFF2-40B4-BE49-F238E27FC236}">
-                    <a16:creationId xmlns:a16="http://schemas.microsoft.com/office/drawing/2014/main" id="{6651B796-00AD-4CE7-6AA6-7436EC5AE920}"/>
-                  </a:ext>
-                </a:extLst>
-              </p:cNvPr>
-              <p:cNvSpPr/>
-              <p:nvPr/>
-            </p:nvSpPr>
-            <p:spPr>
-              <a:xfrm>
-                <a:off x="8395854" y="514353"/>
-                <a:ext cx="2531679" cy="956148"/>
-              </a:xfrm>
-              <a:prstGeom prst="roundRect">
-                <a:avLst/>
-              </a:prstGeom>
-              <a:noFill/>
-              <a:ln>
-                <a:solidFill>
-                  <a:schemeClr val="tx1"/>
-                </a:solidFill>
-                <a:prstDash val="dash"/>
-              </a:ln>
-            </p:spPr>
-            <p:style>
-              <a:lnRef idx="2">
-                <a:schemeClr val="accent6"/>
-              </a:lnRef>
-              <a:fillRef idx="1">
-                <a:schemeClr val="lt1"/>
-              </a:fillRef>
-              <a:effectRef idx="0">
-                <a:schemeClr val="accent6"/>
-              </a:effectRef>
-              <a:fontRef idx="minor">
-                <a:schemeClr val="dk1"/>
-              </a:fontRef>
-            </p:style>
-            <p:txBody>
-              <a:bodyPr rtlCol="0" anchor="ctr"/>
-              <a:lstStyle/>
-              <a:p>
-                <a:pPr algn="ctr"/>
-                <a:endParaRPr lang="en-US"/>
-              </a:p>
-            </p:txBody>
-          </p:sp>
-        </p:grpSp>
-        <p:cxnSp>
-          <p:nvCxnSpPr>
-            <p:cNvPr id="22" name="Straight Arrow Connector 21">
-              <a:extLst>
-                <a:ext uri="{FF2B5EF4-FFF2-40B4-BE49-F238E27FC236}">
-                  <a16:creationId xmlns:a16="http://schemas.microsoft.com/office/drawing/2014/main" id="{CB03D9E8-C4C3-3598-132C-39B3606E734A}"/>
-                </a:ext>
-              </a:extLst>
-            </p:cNvPr>
-            <p:cNvCxnSpPr>
-              <a:cxnSpLocks/>
-            </p:cNvCxnSpPr>
-            <p:nvPr/>
-          </p:nvCxnSpPr>
-          <p:spPr>
-            <a:xfrm flipH="1">
-              <a:off x="10073390" y="1470501"/>
-              <a:ext cx="465301" cy="713066"/>
-            </a:xfrm>
-            <a:prstGeom prst="straightConnector1">
-              <a:avLst/>
-            </a:prstGeom>
-            <a:ln>
-              <a:solidFill>
-                <a:schemeClr val="tx1"/>
-              </a:solidFill>
-              <a:tailEnd type="triangle"/>
-            </a:ln>
-          </p:spPr>
-          <p:style>
-            <a:lnRef idx="2">
-              <a:schemeClr val="accent1"/>
-            </a:lnRef>
-            <a:fillRef idx="0">
-              <a:schemeClr val="accent1"/>
-            </a:fillRef>
-            <a:effectRef idx="1">
-              <a:schemeClr val="accent1"/>
-            </a:effectRef>
-            <a:fontRef idx="minor">
-              <a:schemeClr val="tx1"/>
-            </a:fontRef>
-          </p:style>
-        </p:cxnSp>
-        <p:sp>
-          <p:nvSpPr>
-            <p:cNvPr id="25" name="TextBox 24">
-              <a:extLst>
-                <a:ext uri="{FF2B5EF4-FFF2-40B4-BE49-F238E27FC236}">
-                  <a16:creationId xmlns:a16="http://schemas.microsoft.com/office/drawing/2014/main" id="{F4D92B22-C206-67E1-6521-92D15260C62C}"/>
-                </a:ext>
-              </a:extLst>
-            </p:cNvPr>
-            <p:cNvSpPr txBox="1"/>
-            <p:nvPr/>
-          </p:nvSpPr>
-          <p:spPr>
-            <a:xfrm>
-              <a:off x="10322450" y="1172795"/>
-              <a:ext cx="640455" cy="312063"/>
-            </a:xfrm>
-            <a:prstGeom prst="rect">
-              <a:avLst/>
-            </a:prstGeom>
-            <a:noFill/>
-          </p:spPr>
-          <p:txBody>
-            <a:bodyPr wrap="square" rtlCol="0">
-              <a:spAutoFit/>
-            </a:bodyPr>
-            <a:lstStyle/>
-            <a:p>
-              <a:r>
-                <a:rPr lang="en-US" sz="1400" dirty="0"/>
-                <a:t>ECN</a:t>
-              </a:r>
-            </a:p>
-          </p:txBody>
-        </p:sp>
-        <p:sp>
-          <p:nvSpPr>
-            <p:cNvPr id="26" name="TextBox 25">
-              <a:extLst>
-                <a:ext uri="{FF2B5EF4-FFF2-40B4-BE49-F238E27FC236}">
-                  <a16:creationId xmlns:a16="http://schemas.microsoft.com/office/drawing/2014/main" id="{DB4AFF59-C1FD-C236-3928-0DBC6AF0A963}"/>
-                </a:ext>
-              </a:extLst>
-            </p:cNvPr>
-            <p:cNvSpPr txBox="1"/>
-            <p:nvPr/>
-          </p:nvSpPr>
-          <p:spPr>
-            <a:xfrm>
-              <a:off x="10193529" y="2076237"/>
-              <a:ext cx="734004" cy="307777"/>
-            </a:xfrm>
-            <a:prstGeom prst="rect">
-              <a:avLst/>
-            </a:prstGeom>
-            <a:noFill/>
-          </p:spPr>
-          <p:txBody>
-            <a:bodyPr wrap="square" rtlCol="0">
-              <a:spAutoFit/>
-            </a:bodyPr>
-            <a:lstStyle/>
-            <a:p>
-              <a:r>
-                <a:rPr lang="en-US" sz="1400" dirty="0"/>
-                <a:t>MPFC</a:t>
-              </a:r>
-            </a:p>
-          </p:txBody>
-        </p:sp>
-      </p:grpSp>
-      <p:grpSp>
-        <p:nvGrpSpPr>
           <p:cNvPr id="42" name="Group 41">
             <a:extLst>
               <a:ext uri="{FF2B5EF4-FFF2-40B4-BE49-F238E27FC236}">
@@ -3708,7 +3357,7 @@
             <p:nvPr/>
           </p:nvPicPr>
           <p:blipFill>
-            <a:blip r:embed="rId5"/>
+            <a:blip r:embed="rId2"/>
             <a:srcRect t="6306" b="6804"/>
             <a:stretch>
               <a:fillRect/>
@@ -3779,7 +3428,7 @@
                 <p:nvPr/>
               </p:nvPicPr>
               <p:blipFill>
-                <a:blip r:embed="rId6"/>
+                <a:blip r:embed="rId3"/>
                 <a:srcRect t="12196" b="47150"/>
                 <a:stretch>
                   <a:fillRect/>
@@ -3810,7 +3459,7 @@
                 <p:nvPr/>
               </p:nvPicPr>
               <p:blipFill>
-                <a:blip r:embed="rId6"/>
+                <a:blip r:embed="rId3"/>
                 <a:srcRect t="53191" r="55236"/>
                 <a:stretch>
                   <a:fillRect/>
@@ -3929,7 +3578,7 @@
             <p:nvPr/>
           </p:nvPicPr>
           <p:blipFill>
-            <a:blip r:embed="rId7"/>
+            <a:blip r:embed="rId4"/>
             <a:srcRect l="43774" t="11624" r="613" b="47471"/>
             <a:stretch>
               <a:fillRect/>
@@ -4029,6 +3678,394 @@
     <p:extLst>
       <p:ext uri="{BB962C8B-B14F-4D97-AF65-F5344CB8AC3E}">
         <p14:creationId xmlns:p14="http://schemas.microsoft.com/office/powerpoint/2010/main" val="650399481"/>
+      </p:ext>
+    </p:extLst>
+  </p:cSld>
+  <p:clrMapOvr>
+    <a:masterClrMapping/>
+  </p:clrMapOvr>
+</p:sld>
+</file>
+
+<file path=ppt/slides/slide2.xml><?xml version="1.0" encoding="utf-8"?>
+<p:sld xmlns:a="http://schemas.openxmlformats.org/drawingml/2006/main" xmlns:r="http://schemas.openxmlformats.org/officeDocument/2006/relationships" xmlns:p="http://schemas.openxmlformats.org/presentationml/2006/main">
+  <p:cSld>
+    <p:spTree>
+      <p:nvGrpSpPr>
+        <p:cNvPr id="1" name="">
+          <a:extLst>
+            <a:ext uri="{FF2B5EF4-FFF2-40B4-BE49-F238E27FC236}">
+              <a16:creationId xmlns:a16="http://schemas.microsoft.com/office/drawing/2014/main" id="{113468C8-65A2-B2AE-9CCB-33A9D88E605F}"/>
+            </a:ext>
+          </a:extLst>
+        </p:cNvPr>
+        <p:cNvGrpSpPr/>
+        <p:nvPr/>
+      </p:nvGrpSpPr>
+      <p:grpSpPr>
+        <a:xfrm>
+          <a:off x="0" y="0"/>
+          <a:ext cx="0" cy="0"/>
+          <a:chOff x="0" y="0"/>
+          <a:chExt cx="0" cy="0"/>
+        </a:xfrm>
+      </p:grpSpPr>
+      <p:grpSp>
+        <p:nvGrpSpPr>
+          <p:cNvPr id="43" name="Group 42">
+            <a:extLst>
+              <a:ext uri="{FF2B5EF4-FFF2-40B4-BE49-F238E27FC236}">
+                <a16:creationId xmlns:a16="http://schemas.microsoft.com/office/drawing/2014/main" id="{7869AACF-B444-7D3A-CC56-051FB5B2C04C}"/>
+              </a:ext>
+            </a:extLst>
+          </p:cNvPr>
+          <p:cNvGrpSpPr/>
+          <p:nvPr/>
+        </p:nvGrpSpPr>
+        <p:grpSpPr>
+          <a:xfrm>
+            <a:off x="408949" y="514353"/>
+            <a:ext cx="3098800" cy="6160767"/>
+            <a:chOff x="7945129" y="514353"/>
+            <a:chExt cx="3098800" cy="6160767"/>
+          </a:xfrm>
+        </p:grpSpPr>
+        <p:pic>
+          <p:nvPicPr>
+            <p:cNvPr id="5" name="Picture 4" descr="A graph with blue lines and white text&#10;&#10;AI-generated content may be incorrect.">
+              <a:extLst>
+                <a:ext uri="{FF2B5EF4-FFF2-40B4-BE49-F238E27FC236}">
+                  <a16:creationId xmlns:a16="http://schemas.microsoft.com/office/drawing/2014/main" id="{CE9CB371-BF19-F5E9-F987-1B5159ED6070}"/>
+                </a:ext>
+              </a:extLst>
+            </p:cNvPr>
+            <p:cNvPicPr>
+              <a:picLocks noChangeAspect="1"/>
+            </p:cNvPicPr>
+            <p:nvPr/>
+          </p:nvPicPr>
+          <p:blipFill>
+            <a:blip r:embed="rId2"/>
+            <a:srcRect t="5083" b="2566"/>
+            <a:stretch>
+              <a:fillRect/>
+            </a:stretch>
+          </p:blipFill>
+          <p:spPr>
+            <a:xfrm>
+              <a:off x="7945129" y="3086100"/>
+              <a:ext cx="3098800" cy="3589020"/>
+            </a:xfrm>
+            <a:prstGeom prst="rect">
+              <a:avLst/>
+            </a:prstGeom>
+          </p:spPr>
+        </p:pic>
+        <p:pic>
+          <p:nvPicPr>
+            <p:cNvPr id="16" name="Picture 15" descr="A close-up of a brain&#10;&#10;AI-generated content may be incorrect.">
+              <a:extLst>
+                <a:ext uri="{FF2B5EF4-FFF2-40B4-BE49-F238E27FC236}">
+                  <a16:creationId xmlns:a16="http://schemas.microsoft.com/office/drawing/2014/main" id="{341A558E-6E71-550C-3291-9A83EF160E20}"/>
+                </a:ext>
+              </a:extLst>
+            </p:cNvPr>
+            <p:cNvPicPr>
+              <a:picLocks noChangeAspect="1"/>
+            </p:cNvPicPr>
+            <p:nvPr/>
+          </p:nvPicPr>
+          <p:blipFill>
+            <a:blip r:embed="rId3"/>
+            <a:srcRect l="45457" t="10580" b="44235"/>
+            <a:stretch>
+              <a:fillRect/>
+            </a:stretch>
+          </p:blipFill>
+          <p:spPr>
+            <a:xfrm>
+              <a:off x="8449381" y="1484858"/>
+              <a:ext cx="1744148" cy="1675984"/>
+            </a:xfrm>
+            <a:prstGeom prst="rect">
+              <a:avLst/>
+            </a:prstGeom>
+          </p:spPr>
+        </p:pic>
+        <p:grpSp>
+          <p:nvGrpSpPr>
+            <p:cNvPr id="18" name="Group 17">
+              <a:extLst>
+                <a:ext uri="{FF2B5EF4-FFF2-40B4-BE49-F238E27FC236}">
+                  <a16:creationId xmlns:a16="http://schemas.microsoft.com/office/drawing/2014/main" id="{C7789DA9-AD17-6C34-3472-489E262CC38E}"/>
+                </a:ext>
+              </a:extLst>
+            </p:cNvPr>
+            <p:cNvGrpSpPr/>
+            <p:nvPr/>
+          </p:nvGrpSpPr>
+          <p:grpSpPr>
+            <a:xfrm>
+              <a:off x="8395854" y="514353"/>
+              <a:ext cx="2531679" cy="956148"/>
+              <a:chOff x="8395854" y="514353"/>
+              <a:chExt cx="2531679" cy="956148"/>
+            </a:xfrm>
+          </p:grpSpPr>
+          <p:grpSp>
+            <p:nvGrpSpPr>
+              <p:cNvPr id="14" name="Group 13">
+                <a:extLst>
+                  <a:ext uri="{FF2B5EF4-FFF2-40B4-BE49-F238E27FC236}">
+                    <a16:creationId xmlns:a16="http://schemas.microsoft.com/office/drawing/2014/main" id="{A6748D8E-E37D-D8F2-9CCB-CC5A77290FF4}"/>
+                  </a:ext>
+                </a:extLst>
+              </p:cNvPr>
+              <p:cNvGrpSpPr/>
+              <p:nvPr/>
+            </p:nvGrpSpPr>
+            <p:grpSpPr>
+              <a:xfrm>
+                <a:off x="8502474" y="528710"/>
+                <a:ext cx="2336059" cy="927433"/>
+                <a:chOff x="831958" y="330200"/>
+                <a:chExt cx="8601328" cy="3414793"/>
+              </a:xfrm>
+            </p:grpSpPr>
+            <p:pic>
+              <p:nvPicPr>
+                <p:cNvPr id="12" name="Picture 11" descr="A group of blue and white brain images&#10;&#10;AI-generated content may be incorrect.">
+                  <a:extLst>
+                    <a:ext uri="{FF2B5EF4-FFF2-40B4-BE49-F238E27FC236}">
+                      <a16:creationId xmlns:a16="http://schemas.microsoft.com/office/drawing/2014/main" id="{919B2668-3FD8-FCB8-C763-DB4A23B87306}"/>
+                    </a:ext>
+                  </a:extLst>
+                </p:cNvPr>
+                <p:cNvPicPr>
+                  <a:picLocks noChangeAspect="1"/>
+                </p:cNvPicPr>
+                <p:nvPr/>
+              </p:nvPicPr>
+              <p:blipFill>
+                <a:blip r:embed="rId4"/>
+                <a:srcRect t="11299" b="48192"/>
+                <a:stretch>
+                  <a:fillRect/>
+                </a:stretch>
+              </p:blipFill>
+              <p:spPr>
+                <a:xfrm>
+                  <a:off x="3520900" y="650929"/>
+                  <a:ext cx="5912386" cy="2778072"/>
+                </a:xfrm>
+                <a:prstGeom prst="rect">
+                  <a:avLst/>
+                </a:prstGeom>
+              </p:spPr>
+            </p:pic>
+            <p:pic>
+              <p:nvPicPr>
+                <p:cNvPr id="13" name="Picture 12" descr="A group of blue and white brain images&#10;&#10;AI-generated content may be incorrect.">
+                  <a:extLst>
+                    <a:ext uri="{FF2B5EF4-FFF2-40B4-BE49-F238E27FC236}">
+                      <a16:creationId xmlns:a16="http://schemas.microsoft.com/office/drawing/2014/main" id="{50AB804C-0E07-91B9-3E5D-55010ABA8EDF}"/>
+                    </a:ext>
+                  </a:extLst>
+                </p:cNvPr>
+                <p:cNvPicPr>
+                  <a:picLocks noChangeAspect="1"/>
+                </p:cNvPicPr>
+                <p:nvPr/>
+              </p:nvPicPr>
+              <p:blipFill>
+                <a:blip r:embed="rId4"/>
+                <a:srcRect t="50207" r="52577"/>
+                <a:stretch>
+                  <a:fillRect/>
+                </a:stretch>
+              </p:blipFill>
+              <p:spPr>
+                <a:xfrm>
+                  <a:off x="831958" y="330200"/>
+                  <a:ext cx="2803793" cy="3414793"/>
+                </a:xfrm>
+                <a:prstGeom prst="rect">
+                  <a:avLst/>
+                </a:prstGeom>
+              </p:spPr>
+            </p:pic>
+          </p:grpSp>
+          <p:sp>
+            <p:nvSpPr>
+              <p:cNvPr id="17" name="Rounded Rectangle 16">
+                <a:extLst>
+                  <a:ext uri="{FF2B5EF4-FFF2-40B4-BE49-F238E27FC236}">
+                    <a16:creationId xmlns:a16="http://schemas.microsoft.com/office/drawing/2014/main" id="{BC163D36-5003-C429-F25E-D0D98CFE13BD}"/>
+                  </a:ext>
+                </a:extLst>
+              </p:cNvPr>
+              <p:cNvSpPr/>
+              <p:nvPr/>
+            </p:nvSpPr>
+            <p:spPr>
+              <a:xfrm>
+                <a:off x="8395854" y="514353"/>
+                <a:ext cx="2531679" cy="956148"/>
+              </a:xfrm>
+              <a:prstGeom prst="roundRect">
+                <a:avLst/>
+              </a:prstGeom>
+              <a:noFill/>
+              <a:ln>
+                <a:solidFill>
+                  <a:schemeClr val="tx1"/>
+                </a:solidFill>
+                <a:prstDash val="dash"/>
+              </a:ln>
+            </p:spPr>
+            <p:style>
+              <a:lnRef idx="2">
+                <a:schemeClr val="accent6"/>
+              </a:lnRef>
+              <a:fillRef idx="1">
+                <a:schemeClr val="lt1"/>
+              </a:fillRef>
+              <a:effectRef idx="0">
+                <a:schemeClr val="accent6"/>
+              </a:effectRef>
+              <a:fontRef idx="minor">
+                <a:schemeClr val="dk1"/>
+              </a:fontRef>
+            </p:style>
+            <p:txBody>
+              <a:bodyPr rtlCol="0" anchor="ctr"/>
+              <a:lstStyle/>
+              <a:p>
+                <a:pPr algn="ctr"/>
+                <a:endParaRPr lang="en-US"/>
+              </a:p>
+            </p:txBody>
+          </p:sp>
+        </p:grpSp>
+        <p:cxnSp>
+          <p:nvCxnSpPr>
+            <p:cNvPr id="22" name="Straight Arrow Connector 21">
+              <a:extLst>
+                <a:ext uri="{FF2B5EF4-FFF2-40B4-BE49-F238E27FC236}">
+                  <a16:creationId xmlns:a16="http://schemas.microsoft.com/office/drawing/2014/main" id="{1A8ED843-F17F-9122-9E11-21115E1E5863}"/>
+                </a:ext>
+              </a:extLst>
+            </p:cNvPr>
+            <p:cNvCxnSpPr>
+              <a:cxnSpLocks/>
+            </p:cNvCxnSpPr>
+            <p:nvPr/>
+          </p:nvCxnSpPr>
+          <p:spPr>
+            <a:xfrm flipH="1">
+              <a:off x="10073390" y="1470501"/>
+              <a:ext cx="465301" cy="713066"/>
+            </a:xfrm>
+            <a:prstGeom prst="straightConnector1">
+              <a:avLst/>
+            </a:prstGeom>
+            <a:ln>
+              <a:solidFill>
+                <a:schemeClr val="tx1"/>
+              </a:solidFill>
+              <a:tailEnd type="triangle"/>
+            </a:ln>
+          </p:spPr>
+          <p:style>
+            <a:lnRef idx="2">
+              <a:schemeClr val="accent1"/>
+            </a:lnRef>
+            <a:fillRef idx="0">
+              <a:schemeClr val="accent1"/>
+            </a:fillRef>
+            <a:effectRef idx="1">
+              <a:schemeClr val="accent1"/>
+            </a:effectRef>
+            <a:fontRef idx="minor">
+              <a:schemeClr val="tx1"/>
+            </a:fontRef>
+          </p:style>
+        </p:cxnSp>
+        <p:sp>
+          <p:nvSpPr>
+            <p:cNvPr id="25" name="TextBox 24">
+              <a:extLst>
+                <a:ext uri="{FF2B5EF4-FFF2-40B4-BE49-F238E27FC236}">
+                  <a16:creationId xmlns:a16="http://schemas.microsoft.com/office/drawing/2014/main" id="{058AE2CE-04B8-2C41-61E0-EE93CD3A519E}"/>
+                </a:ext>
+              </a:extLst>
+            </p:cNvPr>
+            <p:cNvSpPr txBox="1"/>
+            <p:nvPr/>
+          </p:nvSpPr>
+          <p:spPr>
+            <a:xfrm>
+              <a:off x="10322450" y="1172795"/>
+              <a:ext cx="640455" cy="312063"/>
+            </a:xfrm>
+            <a:prstGeom prst="rect">
+              <a:avLst/>
+            </a:prstGeom>
+            <a:noFill/>
+          </p:spPr>
+          <p:txBody>
+            <a:bodyPr wrap="square" rtlCol="0">
+              <a:spAutoFit/>
+            </a:bodyPr>
+            <a:lstStyle/>
+            <a:p>
+              <a:r>
+                <a:rPr lang="en-US" sz="1400" dirty="0"/>
+                <a:t>ECN</a:t>
+              </a:r>
+            </a:p>
+          </p:txBody>
+        </p:sp>
+        <p:sp>
+          <p:nvSpPr>
+            <p:cNvPr id="26" name="TextBox 25">
+              <a:extLst>
+                <a:ext uri="{FF2B5EF4-FFF2-40B4-BE49-F238E27FC236}">
+                  <a16:creationId xmlns:a16="http://schemas.microsoft.com/office/drawing/2014/main" id="{B17AC035-133B-C220-B418-0E35A7EE2DD9}"/>
+                </a:ext>
+              </a:extLst>
+            </p:cNvPr>
+            <p:cNvSpPr txBox="1"/>
+            <p:nvPr/>
+          </p:nvSpPr>
+          <p:spPr>
+            <a:xfrm>
+              <a:off x="10193529" y="2076237"/>
+              <a:ext cx="734004" cy="307777"/>
+            </a:xfrm>
+            <a:prstGeom prst="rect">
+              <a:avLst/>
+            </a:prstGeom>
+            <a:noFill/>
+          </p:spPr>
+          <p:txBody>
+            <a:bodyPr wrap="square" rtlCol="0">
+              <a:spAutoFit/>
+            </a:bodyPr>
+            <a:lstStyle/>
+            <a:p>
+              <a:r>
+                <a:rPr lang="en-US" sz="1400" dirty="0"/>
+                <a:t>MPFC</a:t>
+              </a:r>
+            </a:p>
+          </p:txBody>
+        </p:sp>
+      </p:grpSp>
+    </p:spTree>
+    <p:extLst>
+      <p:ext uri="{BB962C8B-B14F-4D97-AF65-F5344CB8AC3E}">
+        <p14:creationId xmlns:p14="http://schemas.microsoft.com/office/powerpoint/2010/main" val="2275761143"/>
       </p:ext>
     </p:extLst>
   </p:cSld>

</xml_diff>